<commit_message>
added the final presentation
</commit_message>
<xml_diff>
--- a/docs_like_prosals/final_pres_cap_1.pptx
+++ b/docs_like_prosals/final_pres_cap_1.pptx
@@ -3525,7 +3525,7 @@
           <a:p>
             <a:fld id="{762B48F5-BACC-47D6-A0F7-82FBF9C6BC85}" type="datetimeFigureOut">
               <a:rPr lang="en-US"/>
-              <a:t>12/1/2025</a:t>
+              <a:t>12/9/2025</a:t>
             </a:fld>
             <a:endParaRPr/>
           </a:p>
@@ -3690,7 +3690,7 @@
           <a:p>
             <a:fld id="{0CB1CD00-5424-4675-AB18-2C419B060449}" type="datetimeFigureOut">
               <a:rPr lang="en-US"/>
-              <a:t>12/1/2025</a:t>
+              <a:t>12/9/2025</a:t>
             </a:fld>
             <a:endParaRPr/>
           </a:p>
@@ -4335,7 +4335,7 @@
           <a:p>
             <a:fld id="{37CC0096-1860-4642-9CD2-0079EA5E7CD1}" type="datetimeFigureOut">
               <a:rPr lang="en-US" smtClean="0"/>
-              <a:t>12/1/2025</a:t>
+              <a:t>12/9/2025</a:t>
             </a:fld>
             <a:endParaRPr lang="en-US"/>
           </a:p>
@@ -4514,7 +4514,7 @@
           <a:p>
             <a:fld id="{37CC0096-1860-4642-9CD2-0079EA5E7CD1}" type="datetimeFigureOut">
               <a:rPr lang="en-US" smtClean="0"/>
-              <a:t>12/1/2025</a:t>
+              <a:t>12/9/2025</a:t>
             </a:fld>
             <a:endParaRPr lang="en-US"/>
           </a:p>
@@ -4687,7 +4687,7 @@
           <a:p>
             <a:fld id="{37CC0096-1860-4642-9CD2-0079EA5E7CD1}" type="datetimeFigureOut">
               <a:rPr lang="en-US" smtClean="0"/>
-              <a:t>12/1/2025</a:t>
+              <a:t>12/9/2025</a:t>
             </a:fld>
             <a:endParaRPr lang="en-US"/>
           </a:p>
@@ -5120,7 +5120,7 @@
           <a:p>
             <a:fld id="{37CC0096-1860-4642-9CD2-0079EA5E7CD1}" type="datetimeFigureOut">
               <a:rPr lang="en-US" smtClean="0"/>
-              <a:t>12/1/2025</a:t>
+              <a:t>12/9/2025</a:t>
             </a:fld>
             <a:endParaRPr lang="en-US"/>
           </a:p>
@@ -5559,7 +5559,7 @@
           <a:p>
             <a:fld id="{37CC0096-1860-4642-9CD2-0079EA5E7CD1}" type="datetimeFigureOut">
               <a:rPr lang="en-US" smtClean="0"/>
-              <a:t>12/1/2025</a:t>
+              <a:t>12/9/2025</a:t>
             </a:fld>
             <a:endParaRPr lang="en-US"/>
           </a:p>
@@ -5676,7 +5676,7 @@
           <a:p>
             <a:fld id="{37CC0096-1860-4642-9CD2-0079EA5E7CD1}" type="datetimeFigureOut">
               <a:rPr lang="en-US" smtClean="0"/>
-              <a:t>12/1/2025</a:t>
+              <a:t>12/9/2025</a:t>
             </a:fld>
             <a:endParaRPr lang="en-US"/>
           </a:p>
@@ -5771,7 +5771,7 @@
           <a:p>
             <a:fld id="{37CC0096-1860-4642-9CD2-0079EA5E7CD1}" type="datetimeFigureOut">
               <a:rPr lang="en-US" smtClean="0"/>
-              <a:t>12/1/2025</a:t>
+              <a:t>12/9/2025</a:t>
             </a:fld>
             <a:endParaRPr lang="en-US"/>
           </a:p>
@@ -6055,7 +6055,7 @@
           <a:p>
             <a:fld id="{37CC0096-1860-4642-9CD2-0079EA5E7CD1}" type="datetimeFigureOut">
               <a:rPr lang="en-US" smtClean="0"/>
-              <a:t>12/1/2025</a:t>
+              <a:t>12/9/2025</a:t>
             </a:fld>
             <a:endParaRPr lang="en-US"/>
           </a:p>
@@ -6366,7 +6366,7 @@
           <a:p>
             <a:fld id="{37CC0096-1860-4642-9CD2-0079EA5E7CD1}" type="datetimeFigureOut">
               <a:rPr lang="en-US" smtClean="0"/>
-              <a:t>12/1/2025</a:t>
+              <a:t>12/9/2025</a:t>
             </a:fld>
             <a:endParaRPr lang="en-US"/>
           </a:p>
@@ -6598,7 +6598,7 @@
             <a:fld id="{37CC0096-1860-4642-9CD2-0079EA5E7CD1}" type="datetimeFigureOut">
               <a:rPr lang="en-US" smtClean="0"/>
               <a:pPr/>
-              <a:t>12/1/2025</a:t>
+              <a:t>12/9/2025</a:t>
             </a:fld>
             <a:endParaRPr lang="en-US"/>
           </a:p>
@@ -7027,12 +7027,19 @@
             <a:spLocks noGrp="1"/>
           </p:cNvSpPr>
           <p:nvPr>
-            <p:ph type="ctrTitle"/>
+            <p:ph type="title"/>
           </p:nvPr>
         </p:nvSpPr>
-        <p:spPr/>
+        <p:spPr>
+          <a:xfrm>
+            <a:off x="1524000" y="1828800"/>
+            <a:ext cx="9144000" cy="2743200"/>
+          </a:xfrm>
+        </p:spPr>
         <p:txBody>
-          <a:bodyPr/>
+          <a:bodyPr anchor="b">
+            <a:normAutofit/>
+          </a:bodyPr>
           <a:lstStyle/>
           <a:p>
             <a:r>
@@ -7050,25 +7057,36 @@
             <a:spLocks noGrp="1"/>
           </p:cNvSpPr>
           <p:nvPr>
-            <p:ph type="subTitle" idx="1"/>
+            <p:ph type="body" idx="1"/>
           </p:nvPr>
         </p:nvSpPr>
-        <p:spPr/>
+        <p:spPr>
+          <a:xfrm>
+            <a:off x="1524000" y="4589463"/>
+            <a:ext cx="9144000" cy="1506537"/>
+          </a:xfrm>
+        </p:spPr>
         <p:txBody>
-          <a:bodyPr/>
+          <a:bodyPr>
+            <a:normAutofit/>
+          </a:bodyPr>
           <a:lstStyle/>
           <a:p>
+            <a:pPr>
+              <a:spcAft>
+                <a:spcPts val="600"/>
+              </a:spcAft>
+            </a:pPr>
             <a:r>
               <a:rPr lang="en-CA" dirty="0"/>
               <a:t>Yaksh Aaryan Harman Raman Fadil</a:t>
             </a:r>
-            <a:endParaRPr dirty="0"/>
           </a:p>
         </p:txBody>
       </p:sp>
       <p:pic>
         <p:nvPicPr>
-          <p:cNvPr id="6148" name="Picture 4">
+          <p:cNvPr id="4" name="Picture 4">
             <a:extLst>
               <a:ext uri="{FF2B5EF4-FFF2-40B4-BE49-F238E27FC236}">
                 <a16:creationId xmlns:a16="http://schemas.microsoft.com/office/drawing/2014/main" id="{23F27163-284F-4CCB-8E5A-0238EC380B4C}"/>
@@ -7115,7 +7133,7 @@
       </p:pic>
       <p:pic>
         <p:nvPicPr>
-          <p:cNvPr id="6147" name="Picture 3" descr="A black and green background&#10;&#10;Description automatically generated">
+          <p:cNvPr id="5" name="Picture 3" descr="A black and green background&#10;&#10;Description automatically generated">
             <a:extLst>
               <a:ext uri="{FF2B5EF4-FFF2-40B4-BE49-F238E27FC236}">
                 <a16:creationId xmlns:a16="http://schemas.microsoft.com/office/drawing/2014/main" id="{A641314E-2C06-6A33-F14D-F7F7878CF3FD}"/>
@@ -7162,7 +7180,7 @@
       </p:pic>
       <p:pic>
         <p:nvPicPr>
-          <p:cNvPr id="6146" name="Picture 2" descr="A logo with a green circle and white text&#10;&#10;Description automatically generated">
+          <p:cNvPr id="6" name="Picture 2" descr="A logo with a green circle and white text&#10;&#10;Description automatically generated">
             <a:extLst>
               <a:ext uri="{FF2B5EF4-FFF2-40B4-BE49-F238E27FC236}">
                 <a16:creationId xmlns:a16="http://schemas.microsoft.com/office/drawing/2014/main" id="{39A7E851-9557-04B1-F1E3-D2CDA7C33759}"/>

</xml_diff>